<commit_message>
La empresa pasa a llamarse Burglar King (antes La Plancha)
Memoria, Reto 1 (fuentes + docx/pdf/pptx/html regenerados), figura de red y
comentarios/semillas SQL. La estación de cocina sigue llamándose «plancha»
(es la clave de la estación, no la marca). Migración 28: correo de facturas,
solo si sigue con el valor de fábrica.

Co-Authored-By: Claude Sonnet 5.5 <noreply@anthropic.com>
</commit_message>
<xml_diff>
--- a/docs/reto1/reto1_presentacion.pptx
+++ b/docs/reto1/reto1_presentacion.pptx
@@ -516,7 +516,7 @@
           <a:p>
             <a:r>
               <a:rPr lang="en-US" dirty="0"/>
-              <a:t>Presentamos el análisis del contexto tecnológico de La Plancha, la empresa para la que estamos desarrollando el TPV con pantallas de cocina. El objetivo del reto es entender qué tecnología tiene hoy la empresa, en qué entorno se mueve y qué necesita, antes de proponer nada. El título lo resume: vamos a mirar lo que hay detrás de la barra.</a:t>
+              <a:t>Presentamos el análisis del contexto tecnológico de Burglar King, la empresa para la que estamos desarrollando el TPV con pantallas de cocina. El objetivo del reto es entender qué tecnología tiene hoy la empresa, en qué entorno se mueve y qué necesita, antes de proponer nada. El título lo resume: vamos a mirar lo que hay detrás de la barra.</a:t>
             </a:r>
             <a:endParaRPr lang="en-US" dirty="0"/>
           </a:p>
@@ -604,7 +604,7 @@
           <a:p>
             <a:r>
               <a:rPr lang="en-US" dirty="0"/>
-              <a:t>El análisis PESTEL. En lo político y legal, lo que más pesa es Verifactu: desde el 1 de enero de 2027 una sociedad como La Plancha necesita un sistema de facturación adaptado, y su TPV de 2016 sin mantenimiento no lo estará. En lo económico, márgenes estrechos. En lo social, un cliente joven que paga con el móvil, así que el datáfono tiene que funcionar también en la terraza. En lo tecnológico, el fin de Windows 10 y una digitalización que se ha quedado en el cobro y no ha llegado a la cocina. En lo ambiental, el papel térmico y los residuos electrónicos. Y en lo legal, además, protección de datos con las cámaras, alérgenos y registro de jornada.</a:t>
+              <a:t>El análisis PESTEL. En lo político y legal, lo que más pesa es Verifactu: desde el 1 de enero de 2027 una sociedad como Burglar King necesita un sistema de facturación adaptado, y su TPV de 2016 sin mantenimiento no lo estará. En lo económico, márgenes estrechos. En lo social, un cliente joven que paga con el móvil, así que el datáfono tiene que funcionar también en la terraza. En lo tecnológico, el fin de Windows 10 y una digitalización que se ha quedado en el cobro y no ha llegado a la cocina. En lo ambiental, el papel térmico y los residuos electrónicos. Y en lo legal, además, protección de datos con las cámaras, alérgenos y registro de jornada.</a:t>
             </a:r>
             <a:endParaRPr lang="en-US" dirty="0"/>
           </a:p>
@@ -956,7 +956,7 @@
           <a:p>
             <a:r>
               <a:rPr lang="en-US" dirty="0"/>
-              <a:t>Para terminar. La Plancha tiene tres problemas de fondo: trabaja a ciegas durante el servicio, guarda sus datos en un equipo sin soporte y sin copias, y comparte una red plana con sus clientes. El entorno añade una fecha, Verifactu, y una oportunidad, el hardware barato y un software sin cuotas por pantalla. Y la conclusión que más nos ha sorprendido: las medidas más urgentes casi no cuestan dinero. No falta dinero; falta alguien que diseñe la infraestructura y la deje funcionando sola. Eso es lo que haremos en los próximos retos: diseño, viabilidad, presupuesto, documentación y plan de intervención.</a:t>
+              <a:t>Para terminar. Burglar King tiene tres problemas de fondo: trabaja a ciegas durante el servicio, guarda sus datos en un equipo sin soporte y sin copias, y comparte una red plana con sus clientes. El entorno añade una fecha, Verifactu, y una oportunidad, el hardware barato y un software sin cuotas por pantalla. Y la conclusión que más nos ha sorprendido: las medidas más urgentes casi no cuestan dinero. No falta dinero; falta alguien que diseñe la infraestructura y la deje funcionando sola. Eso es lo que haremos en los próximos retos: diseño, viabilidad, presupuesto, documentación y plan de intervención.</a:t>
             </a:r>
             <a:endParaRPr lang="en-US" dirty="0"/>
           </a:p>
@@ -1132,7 +1132,7 @@
           <a:p>
             <a:r>
               <a:rPr lang="en-US" dirty="0"/>
-              <a:t>La Plancha es una hamburguesería de barrio en Burjassot, al lado del campus de la Universitat de València. Tiene trece mesas y cuatro personas: el encargado, dos camareros y una cocinera. Es una empresa ficticia, como permite el enunciado, pero la hemos construido con datos reales del sector. Pertenece al grupo más numeroso de la hostelería: el local independiente, que es el 93 por ciento de los establecimientos. Lo importante es que el servicio se concentra en franjas cortas, y ahí es donde la tecnología no puede fallar.</a:t>
+              <a:t>Burglar King es una hamburguesería de barrio en Burjassot, al lado del campus de la Universitat de València. Tiene trece mesas y cuatro personas: el encargado, dos camareros y una cocinera. Es una empresa ficticia, como permite el enunciado, pero la hemos construido con datos reales del sector. Pertenece al grupo más numeroso de la hostelería: el local independiente, que es el 93 por ciento de los establecimientos. Lo importante es que el servicio se concentra en franjas cortas, y ahí es donde la tecnología no puede fallar.</a:t>
             </a:r>
             <a:endParaRPr lang="en-US" dirty="0"/>
           </a:p>
@@ -1748,7 +1748,7 @@
           <a:p>
             <a:r>
               <a:rPr lang="en-US" dirty="0"/>
-              <a:t>Ahora el entorno. La hostelería española tiene más de 280.000 establecimientos y el 93 por ciento son independientes, como La Plancha. En la Comunitat Valenciana hay más de 31.000 bares y restaurantes, uno por cada 174 habitantes. Y el dato clave: el sector factura más, pero la restauración tuvo rentabilidad negativa en 2025. Conclusión para el proyecto: cualquier inversión se mide en euros ahorrados, no en funciones.</a:t>
+              <a:t>Ahora el entorno. La hostelería española tiene más de 280.000 establecimientos y el 93 por ciento son independientes, como Burglar King. En la Comunitat Valenciana hay más de 31.000 bares y restaurantes, uno por cada 174 habitantes. Y el dato clave: el sector factura más, pero la restauración tuvo rentabilidad negativa en 2025. Conclusión para el proyecto: cualquier inversión se mide en euros ahorrados, no en funciones.</a:t>
             </a:r>
             <a:endParaRPr lang="en-US" dirty="0"/>
           </a:p>
@@ -2257,7 +2257,7 @@
                 <a:ea typeface="Arial" pitchFamily="34" charset="-122"/>
                 <a:cs typeface="Arial" pitchFamily="34" charset="-120"/>
               </a:rPr>
-              <a:t>Análisis del contexto tecnológico de La Plancha</a:t>
+              <a:t>Análisis del contexto tecnológico de Burglar King</a:t>
             </a:r>
             <a:endParaRPr lang="en-US" sz="2400" dirty="0"/>
           </a:p>
@@ -6809,7 +6809,7 @@
                 <a:ea typeface="Arial" pitchFamily="34" charset="-122"/>
                 <a:cs typeface="Arial" pitchFamily="34" charset="-120"/>
               </a:rPr>
-              <a:t>Informe completo: «Análisis del contexto tecnológico de La Plancha» (Reto 1).</a:t>
+              <a:t>Informe completo: «Análisis del contexto tecnológico de Burglar King» (Reto 1).</a:t>
             </a:r>
             <a:endParaRPr lang="en-US" sz="1800" dirty="0"/>
           </a:p>
@@ -6919,7 +6919,7 @@
                 <a:ea typeface="Arial" pitchFamily="34" charset="-122"/>
                 <a:cs typeface="Arial" pitchFamily="34" charset="-120"/>
               </a:rPr>
-              <a:t>La Plancha: una hamburguesería de barrio</a:t>
+              <a:t>Burglar King: una hamburguesería de barrio</a:t>
             </a:r>
             <a:endParaRPr lang="en-US" sz="3200" dirty="0"/>
           </a:p>
@@ -7538,7 +7538,7 @@
                 <a:ea typeface="Arial" pitchFamily="34" charset="-122"/>
                 <a:cs typeface="Arial" pitchFamily="34" charset="-120"/>
               </a:rPr>
-              <a:t>Empresa ficticia (La Plancha Burjassot, S.L.), construida con datos reales del sector. Restauración independiente, CNAE 56.10.</a:t>
+              <a:t>Empresa ficticia (Burglar King Burjassot, S.L.), construida con datos reales del sector. Restauración independiente, CNAE 56.10.</a:t>
             </a:r>
             <a:endParaRPr lang="en-US" sz="1200" dirty="0"/>
           </a:p>
@@ -7656,7 +7656,7 @@
       </p:sp>
       <p:pic>
         <p:nvPicPr>
-          <p:cNvPr id="4" name="Image 0" descr="/home/roca/kds_tpv/docs/reto1/fig/organigrama.png">    </p:cNvPr>
+          <p:cNvPr id="4" name="Image 0" descr="/home/roca/.tmp_kds_marca/reto1/fig/organigrama.png">    </p:cNvPr>
           <p:cNvPicPr>
             <a:picLocks noChangeAspect="1"/>
           </p:cNvPicPr>
@@ -8001,7 +8001,7 @@
       </p:sp>
       <p:pic>
         <p:nvPicPr>
-          <p:cNvPr id="4" name="Image 0" descr="/home/roca/kds_tpv/docs/reto1/fig/flujo_comanda.png">    </p:cNvPr>
+          <p:cNvPr id="4" name="Image 0" descr="/home/roca/.tmp_kds_marca/reto1/fig/flujo_comanda.png">    </p:cNvPr>
           <p:cNvPicPr>
             <a:picLocks noChangeAspect="1"/>
           </p:cNvPicPr>
@@ -9364,7 +9364,7 @@
       </p:sp>
       <p:pic>
         <p:nvPicPr>
-          <p:cNvPr id="4" name="Image 0" descr="/home/roca/kds_tpv/docs/reto1/fig/red_actual.png">    </p:cNvPr>
+          <p:cNvPr id="4" name="Image 0" descr="/home/roca/.tmp_kds_marca/reto1/fig/red_actual.png">    </p:cNvPr>
           <p:cNvPicPr>
             <a:picLocks noChangeAspect="1"/>
           </p:cNvPicPr>

</xml_diff>

<commit_message>
Reto 1: guion hablado de 30 minutos (guion.json) y título de riesgos corregido
Las notas del orador pasan de ~770 a ~3.900 palabras (31 min a 125 ppm), en un único
guion.json que leen el HTML y el pptx (antes cada uno tenía su texto). Escrito sobre el
informe, con verificación de cifras y afirmaciones contra él. El HTML gana cabecera con
el tiempo por diapositiva y un cronómetro de ensayo (tecla T).

Corrección: el título de la diapositiva 8 y la frase del apartado 4.5 decían «la mitad»
de riesgos críticos; la tabla da seis de diez.

Co-Authored-By: Claude Sonnet 5.5 <noreply@anthropic.com>
</commit_message>
<xml_diff>
--- a/docs/reto1/reto1_presentacion.pptx
+++ b/docs/reto1/reto1_presentacion.pptx
@@ -516,7 +516,10 @@
           <a:p>
             <a:r>
               <a:rPr lang="en-US" dirty="0"/>
-              <a:t>Presentamos el análisis del contexto tecnológico de Burglar King, la empresa para la que estamos desarrollando el TPV con pantallas de cocina. El objetivo del reto es entender qué tecnología tiene hoy la empresa, en qué entorno se mueve y qué necesita, antes de proponer nada. El título lo resume: vamos a mirar lo que hay detrás de la barra.</a:t>
+              <a:t>Hola, somos Riches Manuel y Roca, de primero de ASIR, Administración de Sistemas Informáticos en Red, en el IES Conselleria. Presentamos el Reto 1 del Proyecto Intermodular I.
+Un restaurante pequeño casi nunca tiene departamento de informática. Tiene un ordenador en la caja, un router, el aparato que da internet, y móviles personales que son herramientas de trabajo. Eso es lo que hay detrás de la barra.
+Nuestro caso es Burglar King, una hamburguesería de barrio ficticia, con datos reales del sector, la normativa y el mercado. Los equipos y su estado son inventados, aunque verosímiles. Para ella desarrollamos un nuevo sistema de punto de venta, un TPV, el programa de cobro, con pantallas de cocina, los KDS.
+Veremos el local por dentro, su entorno, y qué necesita y qué debe cumplir el proyecto.</a:t>
             </a:r>
             <a:endParaRPr lang="en-US" dirty="0"/>
           </a:p>
@@ -604,7 +607,14 @@
           <a:p>
             <a:r>
               <a:rPr lang="en-US" dirty="0"/>
-              <a:t>El análisis PESTEL. En lo político y legal, lo que más pesa es Verifactu: desde el 1 de enero de 2027 una sociedad como Burglar King necesita un sistema de facturación adaptado, y su TPV de 2016 sin mantenimiento no lo estará. En lo económico, márgenes estrechos. En lo social, un cliente joven que paga con el móvil, así que el datáfono tiene que funcionar también en la terraza. En lo tecnológico, el fin de Windows 10 y una digitalización que se ha quedado en el cobro y no ha llegado a la cocina. En lo ambiental, el papel térmico y los residuos electrónicos. Y en lo legal, además, protección de datos con las cámaras, alérgenos y registro de jornada.</a:t>
+              <a:t>Esos factores los ordenamos con PESTEL, una sigla cuyas letras son familias de factores externos: político, económico, social, tecnológico, ambiental y legal.
+Empezamos por lo político, donde manda la ley. La ley antifraude prohíbe el software de facturación capaz de ocultar o alterar ventas. Verifactu es el reglamento que exige registrar y encadenar cada factura. Según Garrigues, 2025, el nuevo plazo es el uno de enero de 2027 para las sociedades, como Burglar King, y el uno de julio de 2027 para el resto. Y su licencia de caja, de 2016 y sin mantenimiento, no se adaptará.
+Lo económico ya lo vimos: cada euro cuenta.
+En lo social, el cliente es joven, paga con tarjeta o con el móvil y espera wifi. Un fabricante de TPV sitúa entre el 65 y el 70 por ciento los pagos digitales en hostelería, según El Independiente, 2026: un indicio, no estadística oficial. El datáfono debe cobrar también en la terraza, y el wifi de los clientes debe ir en otra red.
+En lo tecnológico, el fin de Windows 10 obliga a renovar la caja. Según el estudio de mercado de nuestro proyecto, de 2026, la digitalización del sector se ha concentrado en el cobro y la producción sigue con papel y a voz: la oportunidad está entre la comanda y el plato.
+En lo ambiental, Europa restringe el bisfenol A, una sustancia química, en el papel térmico de los tickets. Imprimir menos reduce residuos y gasto: ticket en pantalla y papel solo a petición. Y los equipos viejos se entregan como RAEE: residuos de aparatos eléctricos y electrónicos.
+Y en lo legal, además, están el RGPD, el reglamento europeo de protección de datos, y la ley orgánica española de 2018. Para las cámaras exigen cartel y limitan a un mes la conservación de las imágenes, salvo que acrediten un delito. Quedan los alérgenos y el registro de jornada: apuntar cuándo entra y sale cada trabajador.
+Veamos ahora a quienes tratan con el local.</a:t>
             </a:r>
             <a:endParaRPr lang="en-US" dirty="0"/>
           </a:p>
@@ -692,7 +702,11 @@
           <a:p>
             <a:r>
               <a:rPr lang="en-US" dirty="0"/>
-              <a:t>El microentorno. Los clientes se concentran en franjas cortas: estudiantes que quieren rapidez, familias que dividen la cuenta, pedidos para llevar y reparto. Los proveedores que más importan son los tecnológicos: una operadora con una sola línea, el banco con su datáfono, el fabricante del TPV que ya no da mantenimiento y las plataformas, cuyos pedidos no llegan al TPV. En competencia hay dos planos: las cadenas, que ya llevan la comanda a la cocina en pantalla, y los TPV del mercado, que casi todos cobran por terminal. Nuestro estudio de trece productos lo confirma: añadir una pantalla de cocina es pagar otra licencia. Ahí está el hueco del proyecto.</a:t>
+              <a:t>Del entorno general pasamos al cercano: clientes, proveedores y competencia.
+Los clientes vienen en momentos distintos: estudiantes a mediodía entre semana y de noche de jueves a sábado, familias en fin de semana, pedidos para llevar a todas horas, con pico a la cena, y reparto en noches y fines de semana. Ya dijimos que las franjas son cortas: la tecnología no puede fallar en hora punta, y tampoco si se cae internet.
+Los proveedores de comida y bebida son sobre todo cash and carry, mayoristas de autoservicio, según Makro España y GM Cash, 2026. Pero nos importan los proveedores TIC, de tecnologías de la información y la comunicación. Tres tienen dependencia alta: la operadora, con una sola línea y un router que el local no controla; el banco, cuyo datáfono necesita red estable en toda la superficie, terraza incluida; y el fabricante del TPV, con una licencia de 2016 sin mantenimiento. Las plataformas de reparto, dependencia media: cobran comisión y sus pedidos no llegan al TPV.
+En competencia hay dos planos. En el del negocio compiten hamburgueserías del barrio, cocinas que solo venden por plataformas y cadenas, las que tienen la comanda en pantalla de cocina y un monitor donde el cliente ve cuándo está listo su pedido. En el tecnológico, el estudio de mercado del proyecto ve tres capas: licencia por terminal, suscripción por terminal o por local, y gratuitas que cobran por complementos y por los datos. Casi todas cobran por terminal o pantalla: cada pantalla de cocina es otra cuota. Ahí está el hueco.
+Con el entorno claro, toca decidir qué necesita Burglar King.</a:t>
             </a:r>
             <a:endParaRPr lang="en-US" dirty="0"/>
           </a:p>
@@ -780,7 +794,14 @@
           <a:p>
             <a:r>
               <a:rPr lang="en-US" dirty="0"/>
-              <a:t>Cruzando lo interno con el entorno salen siete necesidades. Las tres primeras son las urgentes: separar la red, hacer copias con un SAI y cambiar la caja por un sistema con soporte y adaptable a Verifactu. Después, llevar la comanda a la cocina en pantalla, que es el corazón del negocio; cuentas individuales; wifi profesional y adecuar las cámaras al RGPD. El tipo de proyecto que responde a esto es una implantación de infraestructura: red segmentada, un servidor local con nuestro TPV y KDS, los puestos de sala y cocina, y copias y supervisión.</a:t>
+              <a:t>Cruzamos ahora el análisis interno con el del entorno, y salen siete necesidades. Las ordenamos por urgencia, según el riesgo que cubren y las fechas legales.
+La primera, separar la red: riesgo crítico, coste bajo y requisito para todo lo demás. Es la que cubre más riesgos, cuatro de los diez, entre ellos el grabador expuesto.
+La segunda, copias automáticas y SAI: hoy un fallo de disco o un corte de luz se lleva el negocio. Decimos verificadas porque una copia que nadie ha probado a restaurar es solo una esperanza.
+La tercera, una caja con soporte y adaptable a Verifactu: coinciden una obligación con fecha, el uno de enero de 2027, y un sistema sin actualizaciones.
+La cuarta es la comanda en pantalla de cocina con tiempos, la que ya vimos. No cubre ninguno de los diez riesgos, pero es el flujo central del negocio. Aquí encaja el software que estamos desarrollando.
+La quinta, cuentas individuales y datos fuera de lo personal. La ley antifraude exige trazabilidad, y con la cuenta compartida no la hay. Y hay que sacar del móvil personal del encargado lo que es del negocio.
+La sexta, wifi profesional: hoy hay un solo punto de acceso, en el almacén, y el datáfono pierde conexión. La séptima, las cámaras: grabador expuesto y sin cartel; hay que ponerlas conforme al RGPD.
+La respuesta es un proyecto de implantación: rehacer la red en partes separadas, montar un servidor propio, poner los puestos de sala y cocina, y dejar copias y supervisión funcionando. Falta saber cómo comprobaremos que está bien hecho.</a:t>
             </a:r>
             <a:endParaRPr lang="en-US" dirty="0"/>
           </a:p>
@@ -868,7 +889,13 @@
           <a:p>
             <a:r>
               <a:rPr lang="en-US" dirty="0"/>
-              <a:t>De las necesidades salen las características que tendrá que cumplir el proyecto, y que servirán para evaluarlo: funcionar sin internet, al menos cuatro redes separadas, todo el tráfico cifrado, restaurar el sistema en menos de una hora, un PIN por persona para que cada cobro tenga autor, y cero euros de cuota por pantalla. Hay fechas que obligan: Verifactu el 1 de enero de 2027 para sociedades. También recogemos las obligaciones fiscales, laborales y de prevención, y las ayudas posibles, como el Kit Digital; como dependen de convocatorias, el presupuesto se hará sin contar con ellas.</a:t>
+              <a:t>Lo comprobaremos con ocho características medibles del proyecto.
+Primera: sin internet se sigue tomando nota y enviando a cocina, gracias al servidor del local, y cobrando con tarjeta por la conexión móvil, el 4G, del datáfono. Hoy el datáfono trae 4G, pero va por el wifi.
+Segunda: cuatro redes separadas, porque hoy el móvil de un cliente comparte red con la caja; desde la de invitados no se llega a ningún equipo del negocio. Tercera: HTTPS, la versión cifrada del protocolo de la web, entre puestos y servidor.
+Cuarta: restaurar todo en menos de una hora desde una copia diaria verificada; hoy no hay ninguna. Quinta: un PIN, un código personal, por persona: hoy, con una cuenta compartida, nadie sabe quién anula. Sexta: cero euros por terminal o pantalla, el hueco de la competencia. Y otras dos: un SAI, para apagar con orden, y facilidad de uso.
+Hay fechas que obligan, las de Verifactu que ya vimos: a Burglar King, como sociedad, le toca el primer plazo, el uno de enero de 2027.
+Y otras obligaciones condicionan el diseño. El IVA, el impuesto sobre el valor añadido, al diez por ciento: tickets y facturas con numeración correlativa. El registro de jornada se puede hacer con el PIN de cada persona. Las pantallas de cocina, protegidas del calor y la grasa. Y el RGPD: el mínimo de datos personales.
+Las ayudas, como Kit Digital, de Red.es, o las de la Generalitat Valenciana que gestiona el IVACE+i, su instituto de competitividad empresarial, dependen de convocatorias con fondos limitados. Por eso el presupuesto irá sin ellas. Y con eso, toca cerrar.</a:t>
             </a:r>
             <a:endParaRPr lang="en-US" dirty="0"/>
           </a:p>
@@ -956,7 +983,11 @@
           <a:p>
             <a:r>
               <a:rPr lang="en-US" dirty="0"/>
-              <a:t>Para terminar. Burglar King tiene tres problemas de fondo: trabaja a ciegas durante el servicio, guarda sus datos en un equipo sin soporte y sin copias, y comparte una red plana con sus clientes. El entorno añade una fecha, Verifactu, y una oportunidad, el hardware barato y un software sin cuotas por pantalla. Y la conclusión que más nos ha sorprendido: las medidas más urgentes casi no cuestan dinero. No falta dinero; falta alguien que diseñe la infraestructura y la deje funcionando sola. Eso es lo que haremos en los próximos retos: diseño, viabilidad, presupuesto, documentación y plan de intervención.</a:t>
+              <a:t>Esto es lo que nos llevamos.
+Burglar King es un caso típico: un negocio que funciona, en un sector de márgenes estrechos, con una tecnología acumulada sin diseño. Vemos tres problemas de fondo. Trabaja a ciegas: la comanda no entra en ningún sistema hasta el cobro. Guarda los datos del negocio en un equipo sin soporte, con el disco fallando y sin copias. Y comparte red con los móviles de los clientes y con un grabador expuesto en internet.
+El entorno suma urgencia y oportunidad. Urgencia: Verifactu, el uno de enero de 2027, y renovar la caja por el fin de Windows 10. Oportunidad: hardware asequible y, con este proyecto, software sin cuotas por pantalla.
+Como adelantamos con los riesgos, separar redes, cambiar contraseñas y hacer copias cuesta muy poco, aunque el sector apriete. Si no se ha hecho, no es por dinero: nadie en la empresa tiene el conocimiento ni el encargo. Falta alguien que diseñe la infraestructura y la deje funcionando sola.
+Nuestro guion de trabajo prevé, del Reto 2 al 6: diseño, viabilidad, presupuesto con comparación a cinco años, documentación con plan de pruebas y plan de intervención. Se ajustará cuando salgan los enunciados. Pasamos a las preguntas.</a:t>
             </a:r>
             <a:endParaRPr lang="en-US" dirty="0"/>
           </a:p>
@@ -1044,7 +1075,7 @@
           <a:p>
             <a:r>
               <a:rPr lang="en-US" dirty="0"/>
-              <a:t>Gracias. Quedamos abiertos a preguntas. Todas las fuentes están citadas en formato APA en el informe.</a:t>
+              <a:t>Hasta aquí el Reto 1. Las cifras y las fuentes que hemos citado están en el informe completo, con las referencias en formato APA, un modo habitual de citar fuentes, y la normativa publicada en el Boletín Oficial del Estado y en el Diario Oficial de la Unión Europea. Gracias por escucharnos. Ahora os toca a vosotros: preguntad lo que queráis.</a:t>
             </a:r>
             <a:endParaRPr lang="en-US" dirty="0"/>
           </a:p>
@@ -1132,7 +1163,11 @@
           <a:p>
             <a:r>
               <a:rPr lang="en-US" dirty="0"/>
-              <a:t>Burglar King es una hamburguesería de barrio en Burjassot, al lado del campus de la Universitat de València. Tiene trece mesas y cuatro personas: el encargado, dos camareros y una cocinera. Es una empresa ficticia, como permite el enunciado, pero la hemos construido con datos reales del sector. Pertenece al grupo más numeroso de la hostelería: el local independiente, que es el 93 por ciento de los establecimientos. Lo importante es que el servicio se concentra en franjas cortas, y ahí es donde la tecnología no puede fallar.</a:t>
+              <a:t>Vamos con el local.
+Burglar King está en Burjassot, municipio del área metropolitana de València que acoge el campus de Burjassot-Paterna de la Universitat de València. Eso determina el negocio: mucha gente joven y universitaria, demanda concentrada en franjas cortas, a mediodía y por la noche, y muchos pedidos para llevar o a domicilio.
+El ticket medio, lo que gasta de media cada comensal, va de quince a veinticinco euros. Vende por cuatro canales, y el reparto a domicilio lo hace con dos plataformas. Es una sociedad limitada y su actividad es el CNAE 56.10, la Clasificación Nacional de Actividades Económicas: el código que etiqueta cada tipo de negocio, aquí restaurantes y puestos de comidas.
+Es un caso típico. Según Profesional Horeca, 2025, la restauración independiente, la que no es cadena, reúne el 93 por ciento de los establecimientos. Por tamaño es una microempresa, la que tiene menos de diez trabajadores, y las más pequeñas son la gran mayoría: según el Instituto Nacional de Estadística, el INE, en 2025, el 81,6 por ciento de las empresas españolas tiene dos asalariados o menos.
+Eso importa para el proyecto. El cliente típico de una solución así no tiene a nadie que sepa de informática, y lo que montemos tiene que funcionar sin un técnico presente. Además, en hora punta la tecnología no puede fallar, y con tanta gente a la vez y tanto pedido para llevar el papel es lo que peor lo lleva, como veremos con el recorrido de un pedido. Pero primero, ¿quién lleva todo esto? Mirad el organigrama.</a:t>
             </a:r>
             <a:endParaRPr lang="en-US" dirty="0"/>
           </a:p>
@@ -1220,7 +1255,12 @@
           <a:p>
             <a:r>
               <a:rPr lang="en-US" dirty="0"/>
-              <a:t>La estructura es plana: sala, cocina y una persona que lo concentra todo. Ese es el primer hallazgo: el encargado es dirección, compras, caja, administración y, en la práctica, el único responsable de informática. Si él falta un día, nadie sabe reiniciar el router ni recuperar la contraseña del TPV. Igual que hay puntos únicos de fallo técnicos, aquí hay uno humano.</a:t>
+              <a:t>Lo lleva muy poca gente, y eso tiene consecuencias.
+La estructura es plana, la de cualquier microempresa de hostelería. No hay departamentos de verdad, sino dos áreas operativas. En la sala, dos camareros atienden mesas, terraza y barra, toman nota y cobran. En la cocina, una cocinera prepara en plancha, freidora y fríos, y también los pedidos de reparto. Y fijaos: la cocina no usa ninguna tecnología. Las comandas, que son los pedidos de cada mesa, le llegan en papel y de viva voz.
+Luego está el encargado, que además es el socio gerente. Concentra la dirección y todo el apoyo: organiza los turnos y trata con proveedores, plataformas de reparto y la gestoría, la empresa externa que lleva la contabilidad, las nóminas y los impuestos. Trabaja con su portátil, su correo y su móvil con WhatsApp Business, todos personales. Por ese móvil entran las reservas, por llamada o WhatsApp, sin registro común. Si se pierde ese móvil, se van los contactos y el histórico de reservas y proveedores.
+Por eso es, en la práctica, el único responsable de informática. Y si él falta, nadie sabe reiniciar el router, ni consultar un pedido de una plataforma de reparto.
+Eso es un punto único de fallo: una pieza sin sustituto que, si falla, para todo lo que depende de ella. Solemos pensar en equipos que se rompen; aquí es una persona. Es como tener una sola llave del local: el día que no está quien la lleva, nadie entra.
+Y con tanta responsabilidad en una persona, miremos el flujo central del negocio: la comanda.</a:t>
             </a:r>
             <a:endParaRPr lang="en-US" dirty="0"/>
           </a:p>
@@ -1308,7 +1348,13 @@
           <a:p>
             <a:r>
               <a:rPr lang="en-US" dirty="0"/>
-              <a:t>Seguimos la información del proceso central, la comanda. Nace en un comandero de papel, viaja a la cocina pinchada y a voz, se prepara de memoria, sale al pase con un grito y solo entra en un sistema informático en el último paso, cuando el camarero la teclea en el TPV para cobrar. Es decir, el dato llega cuando el cliente ya se va. En cada paso hay un problema: letra ilegible, sin hora, nadie ve el retraso, platos fríos, y el doble tecleo que acaba en descuadres.</a:t>
+              <a:t>Sigamos una comanda paso a paso, desde que se pide hasta que se cobra.
+La comanda nace en la mesa. El camarero la apunta en un comandero de papel, por duplicado, y de ahí viaja en papel y a voz. Una copia se pincha en la cocina y se avisa de palabra. Después la comanda vuelve al pase, que es donde la cocina entrega los platos a la sala. Y solo en el último paso entra por primera vez en un sistema informático: cuando el camarero teclea el pedido en el TPV que tienen hoy, para cobrarlo.
+Por eso el título: el dato llega cuando el cliente ya se va. Durante todo el servicio, que es cuando más importa, el local no tiene ni un dato. No sabe qué mesa lleva más tiempo esperando, qué plato falta ni cuánto tarda la cocina. Y la cocina, como vimos, no tiene hoy ninguna herramienta informática.
+El informe encuentra un fallo en cada paso. Al tomar nota: letra ilegible, notas que se pierden, ninguna hora. En cocina: ni orden fiable ni aviso de retraso. En los pedidos a domicilio, todo llega a la tableta de reparto, donde conviven las dos plataformas, y se copia a mano en papel: doble tecleo, y pedidos que se olvidan en la tableta. Al cobrar, errores de tecleo. Y al cerrar caja, descuadres difíciles de explicar.
+No decimos que se trabaje mal, sino que el sistema no deja huella hasta el final, y sin datos cuesta medir cuánto se tarda o dónde se pierde algo.
+Para el proyecto esto es clave: es el flujo central del negocio y hoy no tiene datos. Por eso llevar la comanda a una pantalla de cocina, con tiempos, es la cuarta necesidad de nuestra lista.
+Veamos ahora con qué equipos se hace todo esto.</a:t>
             </a:r>
             <a:endParaRPr lang="en-US" dirty="0"/>
           </a:p>
@@ -1396,7 +1442,14 @@
           <a:p>
             <a:r>
               <a:rPr lang="en-US" dirty="0"/>
-              <a:t>Este es el inventario. El único equipo que guarda datos del negocio, el PC del TPV, es el más viejo y el que tiene el disco en peor estado. No hay SAI. El router y el grabador están en una balda del almacén, con calor y grasa: no hace falta un CPD, pero sí cuidar las condiciones del equipamiento. El grabador tiene la contraseña de fábrica. Y lo más delicado: los datos del negocio están en el portátil y en el móvil personales del encargado. Además hay cableado cruzando la barra y equipos viejos que deben ir al punto limpio como RAEE.</a:t>
+              <a:t>Estos son esos equipos. Nadie los diseñó: se fueron acumulando. Hemos montado el inventario como si hubiéramos visitado el local con una lista de comprobación, y destacamos seis cosas.
+Primero, el PC del TPV actual: un todo en uno táctil de 2015, con procesador Celeron, cuatro gigas de memoria y un disco duro mecánico de 320 gigas. Arranca lento, y el disco avisa de sectores reasignados: zonas que han fallado y que el disco sustituye por otras de repuesto. Y es el único equipo que guarda la base de datos de ventas, facturas y cierres de caja, justo el más viejo y el de peor disco.
+Segundo, no hay SAI, sistema de alimentación ininterrumpida: una batería que mantiene los equipos encendidos unos minutos cuando se va la luz. Aquí solo hay regletas domésticas, así que un corte apaga el TPV de golpe y puede corromper su base de datos.
+Tercero, el router de la operadora, en una balda del almacén, junto a la cámara frigorífica y cerca de la salida de humos de la cocina. Calor, grasa y humedad acortan la vida de cualquier equipo.
+Cuarto, el grabador de vídeo, en esa misma balda. Su firmware, el programa interno del aparato, es de 2019 y está sin actualizar, así que no tiene las correcciones de seguridad posteriores. Y mantiene las credenciales de fábrica, el usuario y la contraseña que vienen de serie.
+Quinto, la tableta de reparto: Android 9, de 2018, con la batería degradada y siempre enchufada. Y las contraseñas de las plataformas, apuntadas en un pósit en la propia tableta.
+Y sexto, el portátil del encargado y los móviles, todos personales, con las cuentas privadas que los acompañan. Ahí vive una parte del negocio, como vimos con el encargado: correo, reservas y proveedores, facturas escaneadas. Y copias de seguridad, ninguna.
+Equipos viejos, sin actualizar, con claves de fábrica y sin copias. Y todos en la misma red, que vemos ahora.</a:t>
             </a:r>
             <a:endParaRPr lang="en-US" dirty="0"/>
           </a:p>
@@ -1484,7 +1537,13 @@
           <a:p>
             <a:r>
               <a:rPr lang="en-US" dirty="0"/>
-              <a:t>La red es la que dejó la operadora: un router que hace de módem, cortafuegos, DHCP y punto de acceso. Es una estrella con un único dispositivo de interconexión y una sola subred, la 192.168.1.0/24, sin VLAN. Eso significa que el móvil de cualquier cliente está en el mismo dominio de difusión que la caja, el datáfono y el grabador. La clave del wifi está escrita en la pizarra, la del router es la de fábrica y el grabador está expuesto a internet. Además, la cobertura en terraza es mala y el datáfono se desconecta.</a:t>
+              <a:t>Todos esos equipos están conectados entre sí, y ahí aparece otro gran problema: la red.
+La red es la que dejó la operadora. Un único router lo hace todo a la vez: módem de la fibra; cortafuegos, que es el filtro que decide qué tráfico entra y sale; servidor DHCP, que da su dirección a cada aparato cuando se conecta; y punto de acceso wifi.
+Eso significa que el móvil de cualquier cliente está en la misma red que la caja, el datáfono y las cámaras. En redes se dice que comparten el dominio de difusión: todos los aparatos se oyen entre sí. Sirve para una casa, no para un negocio que mezcla un terminal de cobro, un grabador con imágenes de personas y teléfonos de desconocidos.
+Hay más. Un solo SSID, que es el nombre de la wifi, con WPA2, el cifrado habitual de la wifi, en modo de clave compartida: todos entran con la misma contraseña, y está escrita en la pizarra de la sala. Y la contraseña del router es la de fábrica, impresa en su etiqueta: cualquiera con acceso a la red puede cambiar la configuración.
+Luego está el grabador. El router tiene activado UPnP, una función que abre puertos de forma automática, y hay un puerto redirigido para el acceso remoto. Resultado: el grabador se ve desde internet, con sus credenciales de fábrica.
+La conexión también cojea. La fibra es de 600 megas simétricos, pero una sola línea: si se corta, se caen el datáfono por wifi y las plataformas. Y con un único punto de acceso en el almacén, la señal es débil en terraza y cocina.
+La salida, y la primera necesidad de nuestra lista, es separar esa red en segmentos independientes: negocio, cocina, cámaras y clientes. El proyecto exigirá al menos cuatro. Una forma habitual de hacerlo son las VLAN, redes virtuales dentro del mismo cableado, pero cómo se haga se decidirá en el Reto 2. Nos falta ahora mirar dentro de los equipos.</a:t>
             </a:r>
             <a:endParaRPr lang="en-US" dirty="0"/>
           </a:p>
@@ -1572,7 +1631,12 @@
           <a:p>
             <a:r>
               <a:rPr lang="en-US" dirty="0"/>
-              <a:t>En sistemas operativos hay un dato con fecha: el 14 de octubre de 2025 terminó el soporte de Windows 10, que es el sistema del ordenador de cobro. Su procesador no está en la lista de Windows 11, así que no se puede actualizar: hay que sustituirlo o cambiar de sistema. El portátil lleva Windows 11 Home, que no se puede unir a un dominio. Y la información está dispersa: no hay ningún servidor que centralice datos, cuentas ni copias. Para cuatro personas un dominio completo no tiene sentido, pero un servidor local sí.</a:t>
+              <a:t>Dentro de cada equipo corre un sistema operativo, el programa base que hace funcionar lo demás.
+El caso más serio es la caja. El ordenador del TPV actual lleva Windows 10, y el 14 de octubre de 2025 terminó su soporte, según Microsoft, 2025. Soporte quiere decir actualizaciones de seguridad: si aparece un fallo, ya no llega el parche. Existen actualizaciones extendidas, pero el local no las ha contratado. Y tampoco se puede pasar a Windows 11: el procesador no está en la lista de compatibles. Hay que sustituir el equipo o cambiar de sistema operativo. Es como una cerradura rota que el fabricante ya no arregla.
+El portátil del encargado lleva Windows 11 Home. Tiene soporte, pero con dos límites. Primero, no puede unirse a un dominio de Windows. No es el dominio de difusión de antes, sino una red donde un servidor central controla las cuentas de todos los equipos. Segundo, no puede cifrar el disco con BitLocker, la herramienta de Windows que impide leer el disco a quien robe el equipo. Y ese portátil sale del local.
+La tableta tiene Android 9, sin parches, y el grabador sigue con el firmware de 2019 que ya vimos.
+Lo de fondo es que no hay ningún servidor. Los datos están repartidos entre el disco del TPV, el portátil personal y cuentas personales en la nube. Con cuatro personas, un dominio completo no tendría sentido, pero un servidor local sí, que concentre datos, cuentas individuales y copias. Tendremos que justificarlo en los retos siguientes.
+Con esto el inventario está completo. Toca valorar el riesgo.</a:t>
             </a:r>
             <a:endParaRPr lang="en-US" dirty="0"/>
           </a:p>
@@ -1660,7 +1724,13 @@
           <a:p>
             <a:r>
               <a:rPr lang="en-US" dirty="0"/>
-              <a:t>Valoramos cada riesgo con probabilidad por impacto, de 1 a 3. Salen diez riesgos y seis son críticos. Los dos peores, con un 9: el grabador expuesto en internet con la contraseña de fábrica, y la red única compartida con los clientes. Les siguen la falta de copias, el sistema sin soporte, la cuenta compartida en el TPV, que impide saber quién cobra o anula, y el disco dañado sin SAI. Lo interesante es que casi ninguno exige dinero: separar redes, cambiar contraseñas y hacer copias cuesta muy poco. Falta conocimiento, no presupuesto.</a:t>
+              <a:t>Lo valoramos con una matriz de riesgos sencilla: probabilidad por impacto, de uno a tres cada uno. La probabilidad es lo fácil que es que ocurra; el impacto, lo que dolería si ocurre. Seis o más es crítico; de tres a cuatro, alto; de uno a dos, bajo.
+Salen diez riesgos y ninguno queda en bajo: seis son críticos.
+Se reparten en dos frentes: la red y la caja. Primero, la red. El grabador accesible desde internet con credenciales de fábrica y la red única compartida con los clientes son los dos únicos que llegan al máximo, un nueve: probabilidad tres por impacto tres. Un grabador con imágenes de personas, abierto a internet y con la contraseña de fábrica incumple el deber de seguridad que exige la ley de protección de datos.
+El segundo frente es la caja, y aquí está lo llamativo: cuatro de los seis críticos caen sobre ese mismo ordenador. No tiene copias de su base de datos, funciona con un sistema sin soporte, tiene una única cuenta compartida y un disco con sectores reasignados, y sin SAI. Si cae, cae el negocio. Y con la cuenta compartida no se sabe quién cobra ni quién anula: si la caja no cuadra, no hay forma de saber quién hizo qué.
+Los otros cuatro son altos. Está el router con la contraseña de fábrica y UPnP activado. Están los datos del negocio en cuentas y móviles personales: todo depende de que el encargado siga y no pierda el móvil. Está la videovigilancia sin cartel ni registro actualizado, algo que la ley exige y que veremos con la normativa. Y están las contraseñas a la vista, en un pósit o en la pizarra: probabilidad máxima, impacto bajo, y por eso se quedan en un tres.
+Y las medidas más urgentes no exigen tecnología cara. Separar redes, cambiar credenciales, cerrar el acceso remoto del grabador y empezar a hacer copias cuestan muy poco. Renovar la caja sí tiene un coste, pero el hardware necesario es hoy asequible. Por qué no se han hecho esas medidas, lo diremos al final.
+La pregunta es si el sector deja margen para invertir. Salimos del local para mirarlo desde fuera.</a:t>
             </a:r>
             <a:endParaRPr lang="en-US" dirty="0"/>
           </a:p>
@@ -1748,7 +1818,12 @@
           <a:p>
             <a:r>
               <a:rPr lang="en-US" dirty="0"/>
-              <a:t>Ahora el entorno. La hostelería española tiene más de 280.000 establecimientos y el 93 por ciento son independientes, como Burglar King. En la Comunitat Valenciana hay más de 31.000 bares y restaurantes, uno por cada 174 habitantes. Y el dato clave: el sector factura más, pero la restauración tuvo rentabilidad negativa en 2025. Conclusión para el proyecto: cualquier inversión se mide en euros ahorrados, no en funciones.</a:t>
+              <a:t>Vamos a responderlo con números. Empezamos por el tamaño.
+En España hay más de 280.000 establecimientos de hostelería y el 93 %, la cifra que ya vimos, son locales independientes, como Burglar King; solo una minoría pertenece a cadenas. Ambas cifras, según Profesional Horeca, 2025. Además, el sector da empleo a 1,89 millones de personas, el 8,6 % del empleo total, según Hosteltur, 2026. Es enorme y, a la vez, muy repartido. Y eso refuerza lo que decíamos al principio: cualquier infraestructura que le propongamos a un local así tendrá que funcionar sin un técnico al lado.
+Más cerca de casa: en la Comunitat Valenciana hay 31.186 bares y restaurantes, según El Periòdic, 2025. Es uno por cada 174 habitantes, y 13.698 solo en la provincia de València. Competencia, mucha.
+Y ahora el dato que más condiciona nuestro proyecto. El sector factura más, con crecimientos de entre el 2 y el 4 %, pero la restauración tuvo en 2025 una rentabilidad del menos 0,9 %, según Hosteltur, 2026. Una rentabilidad negativa quiere decir que, pagados los costes, en lugar de beneficio hay pérdida.
+¿Qué significa eso para nosotros? Que una inversión no se justifica por lo que añade, sino por lo que ahorra. Cada cuota pesa: si el local paga por cada terminal o por cada pantalla, se nota. Por eso nuestro proyecto tendrá que demostrar que sale más barato.
+Y el sector no es lo único que condiciona. Hay más factores de fuera que el local no controla. Vamos a verlos.</a:t>
             </a:r>
             <a:endParaRPr lang="en-US" dirty="0"/>
           </a:p>
@@ -10407,7 +10482,7 @@
                 <a:ea typeface="Arial" pitchFamily="34" charset="-122"/>
                 <a:cs typeface="Arial" pitchFamily="34" charset="-120"/>
               </a:rPr>
-              <a:t>Diez riesgos; la mitad, críticos</a:t>
+              <a:t>Diez riesgos; seis, críticos</a:t>
             </a:r>
             <a:endParaRPr lang="en-US" sz="3200" dirty="0"/>
           </a:p>

</xml_diff>

<commit_message>
Reto 1: arreglo de las incoherencias internas del informe
Informe: una sola tableta de reparto (tablas 3, 4.4 y 12); microempresa sin
afirmar que esté entre las de dos asalariados; el PC del TPV es el único equipo con
la base de datos de ventas, facturas y cierres, no con «los datos del negocio»;
segmentos de red = negocio, cocina, cámaras e invitados (tablas 12 y 13); PC de 2015
con más de diez años; el −0,9 % es de la restauración; las medidas más urgentes (no
todas) son de coste casi nulo; 93 % y 7,5 % marcados como cifras redondeadas de la
fuente (suman 100,5 por sí solas); título de 7.3 recoge protección de datos; pie de la
tabla 6 dice que es ficticio.
Diapositivas y guion alineados: «sectores reasignados», «invitados», y el cierre habla
de la base de datos de ventas. Verificado con una auditoría de 7 lentes y 2 verificadores
por hallazgo (29 hallazgos: 8 aplicados, el resto falsos positivos o decisiones de contenido).

Co-Authored-By: Claude Sonnet 5.5 <noreply@anthropic.com>
</commit_message>
<xml_diff>
--- a/docs/reto1/reto1_presentacion.pptx
+++ b/docs/reto1/reto1_presentacion.pptx
@@ -984,7 +984,7 @@
             <a:r>
               <a:rPr lang="en-US" dirty="0"/>
               <a:t>Esto es lo que nos llevamos.
-Burglar King es un caso típico: un negocio que funciona, en un sector de márgenes estrechos, con una tecnología acumulada sin diseño. Vemos tres problemas de fondo. Trabaja a ciegas: la comanda no entra en ningún sistema hasta el cobro. Guarda los datos del negocio en un equipo sin soporte, con el disco fallando y sin copias. Y comparte red con los móviles de los clientes y con un grabador expuesto en internet.
+Burglar King es un caso típico: un negocio que funciona, en un sector de márgenes estrechos, con una tecnología acumulada sin diseño. Vemos tres problemas de fondo. Trabaja a ciegas: la comanda no entra en ningún sistema hasta el cobro. Guarda la base de datos de ventas, facturas y cierres de caja en un equipo sin soporte, con el disco fallando y sin copias. Y comparte red con los móviles de los clientes y con un grabador expuesto en internet.
 El entorno suma urgencia y oportunidad. Urgencia: Verifactu, el uno de enero de 2027, y renovar la caja por el fin de Windows 10. Oportunidad: hardware asequible y, con este proyecto, software sin cuotas por pantalla.
 Como adelantamos con los riesgos, separar redes, cambiar contraseñas y hacer copias cuesta muy poco, aunque el sector apriete. Si no se ha hecho, no es por dinero: nadie en la empresa tiene el conocimiento ni el encargo. Falta alguien que diseñe la infraestructura y la deje funcionando sola.
 Nuestro guion de trabajo prevé, del Reto 2 al 6: diseño, viabilidad, presupuesto con comparación a cinco años, documentación con plan de pruebas y plan de intervención. Se ajustará cuando salgan los enunciados. Pasamos a las preguntas.</a:t>
@@ -1543,7 +1543,7 @@
 Hay más. Un solo SSID, que es el nombre de la wifi, con WPA2, el cifrado habitual de la wifi, en modo de clave compartida: todos entran con la misma contraseña, y está escrita en la pizarra de la sala. Y la contraseña del router es la de fábrica, impresa en su etiqueta: cualquiera con acceso a la red puede cambiar la configuración.
 Luego está el grabador. El router tiene activado UPnP, una función que abre puertos de forma automática, y hay un puerto redirigido para el acceso remoto. Resultado: el grabador se ve desde internet, con sus credenciales de fábrica.
 La conexión también cojea. La fibra es de 600 megas simétricos, pero una sola línea: si se corta, se caen el datáfono por wifi y las plataformas. Y con un único punto de acceso en el almacén, la señal es débil en terraza y cocina.
-La salida, y la primera necesidad de nuestra lista, es separar esa red en segmentos independientes: negocio, cocina, cámaras y clientes. El proyecto exigirá al menos cuatro. Una forma habitual de hacerlo son las VLAN, redes virtuales dentro del mismo cableado, pero cómo se haga se decidirá en el Reto 2. Nos falta ahora mirar dentro de los equipos.</a:t>
+La salida, y la primera necesidad de nuestra lista, es separar esa red en segmentos independientes: negocio, cocina, cámaras e invitados. El proyecto exigirá al menos cuatro. Una forma habitual de hacerlo son las VLAN, redes virtuales dentro del mismo cableado, pero cómo se haga se decidirá en el Reto 2. Nos falta ahora mirar dentro de los equipos.</a:t>
             </a:r>
             <a:endParaRPr lang="en-US" dirty="0"/>
           </a:p>
@@ -8437,7 +8437,7 @@
                 <a:ea typeface="Arial" pitchFamily="34" charset="-122"/>
                 <a:cs typeface="Arial" pitchFamily="34" charset="-120"/>
               </a:rPr>
-              <a:t>2015 · Celeron · 4 GB · disco mecánico con sectores dañados</a:t>
+              <a:t>2015 · Celeron · 4 GB · disco mecánico con sectores reasignados</a:t>
             </a:r>
             <a:endParaRPr lang="en-US" sz="1500" dirty="0"/>
           </a:p>

</xml_diff>